<commit_message>
Team day: regenerate PowerPoint deck with July-2026 figures (2026 ESOO)
Demand slides now show Step Change ~329 TWh by 2050 (+86%), the 1.5-2.8x fan, EV
0.9->71 / data centres 5->34 TWh, and the reliability breach years; pipeline slide
adds the 9.1 GW connected / ~40 GW committed+anticipated ESOO figures. Matches the
refreshed HTML pack.

Co-Authored-By: Claude Opus 4.8 <noreply@anthropic.com>
</commit_message>
<xml_diff>
--- a/nem-team-day/Reading-the-NEM-Team-Day.pptx
+++ b/nem-team-day/Reading-the-NEM-Team-Day.pptx
@@ -1176,7 +1176,7 @@
               <c:strCache>
                 <c:ptCount val="1"/>
                 <c:pt idx="0">
-                  <c:v>Step Change forecast</c:v>
+                  <c:v>Step Change forecast (2026 ESOO)</c:v>
                 </c:pt>
               </c:strCache>
             </c:strRef>
@@ -1239,22 +1239,22 @@
                   <c:v>177</c:v>
                 </c:pt>
                 <c:pt idx="4">
-                  <c:v>179</c:v>
+                  <c:v>180</c:v>
                 </c:pt>
                 <c:pt idx="5">
-                  <c:v>192</c:v>
+                  <c:v>197</c:v>
                 </c:pt>
                 <c:pt idx="6">
-                  <c:v>230</c:v>
+                  <c:v>243</c:v>
                 </c:pt>
                 <c:pt idx="7">
-                  <c:v>261</c:v>
+                  <c:v>278</c:v>
                 </c:pt>
                 <c:pt idx="8">
-                  <c:v>278</c:v>
+                  <c:v>305</c:v>
                 </c:pt>
                 <c:pt idx="9">
-                  <c:v>290</c:v>
+                  <c:v>329</c:v>
                 </c:pt>
               </c:numCache>
             </c:numRef>
@@ -10581,7 +10581,7 @@
                 </a:solidFill>
                 <a:latin typeface="Calibri"/>
               </a:rPr>
-              <a:t>Operational demand sat flat ~177 TWh; the ISP central case bends up ~60% by 2050 (the range runs to ~2.4×).</a:t>
+              <a:t>Operational demand sat flat ~177 TWh; the 2026 ESOO central case bends up ~86% by 2050 to ~329 TWh (the range runs to ~2.8×).</a:t>
             </a:r>
           </a:p>
         </p:txBody>
@@ -10974,7 +10974,7 @@
                 </a:solidFill>
                 <a:latin typeface="Calibri"/>
               </a:rPr>
-              <a:t>ISP range to 2050: </a:t>
+              <a:t>2026 ESOO range to 2050: </a:t>
             </a:r>
             <a:r>
               <a:rPr sz="1600" b="1">
@@ -10983,7 +10983,7 @@
                 </a:solidFill>
                 <a:latin typeface="Calibri"/>
               </a:rPr>
-              <a:t>1.6–2.4×</a:t>
+              <a:t>1.5–2.8×</a:t>
             </a:r>
             <a:r>
               <a:rPr sz="1600" b="0">
@@ -10992,7 +10992,25 @@
                 </a:solidFill>
                 <a:latin typeface="Calibri"/>
               </a:rPr>
-              <a:t> (could roughly double); central Step Change ~290 TWh (+62%).</a:t>
+              <a:t>; central Step Change </a:t>
+            </a:r>
+            <a:r>
+              <a:rPr sz="1600" b="1">
+                <a:solidFill>
+                  <a:srgbClr val="111820"/>
+                </a:solidFill>
+                <a:latin typeface="Calibri"/>
+              </a:rPr>
+              <a:t>~329 TWh (+86%)</a:t>
+            </a:r>
+            <a:r>
+              <a:rPr sz="1600" b="0">
+                <a:solidFill>
+                  <a:srgbClr val="37424F"/>
+                </a:solidFill>
+                <a:latin typeface="Calibri"/>
+              </a:rPr>
+              <a:t> — revised up from the ISP's ~290.</a:t>
             </a:r>
           </a:p>
           <a:p>
@@ -11020,7 +11038,7 @@
                 </a:solidFill>
                 <a:latin typeface="Calibri"/>
               </a:rPr>
-              <a:t>EV load 0.9 → 61 TWh</a:t>
+              <a:t>EV load 0.9 → 71 TWh</a:t>
             </a:r>
             <a:r>
               <a:rPr sz="1600" b="0">
@@ -11029,7 +11047,71 @@
                 </a:solidFill>
                 <a:latin typeface="Calibri"/>
               </a:rPr>
-              <a:t> (2026→2050); rooftop installs ~2.7 GW/yr; data centres 4.7 TWh, tripling by 2030.</a:t>
+              <a:t> (2026→2050); </a:t>
+            </a:r>
+            <a:r>
+              <a:rPr sz="1600" b="1">
+                <a:solidFill>
+                  <a:srgbClr val="111820"/>
+                </a:solidFill>
+                <a:latin typeface="Calibri"/>
+              </a:rPr>
+              <a:t>data centres 5 → 34 TWh</a:t>
+            </a:r>
+            <a:r>
+              <a:rPr sz="1600" b="0">
+                <a:solidFill>
+                  <a:srgbClr val="37424F"/>
+                </a:solidFill>
+                <a:latin typeface="Calibri"/>
+              </a:rPr>
+              <a:t> (3%→13%); rooftop installs ~2.7 GW/yr.</a:t>
+            </a:r>
+          </a:p>
+          <a:p>
+            <a:pPr>
+              <a:lnSpc>
+                <a:spcPct val="105000"/>
+              </a:lnSpc>
+              <a:spcAft>
+                <a:spcPts val="1100"/>
+              </a:spcAft>
+            </a:pPr>
+            <a:r>
+              <a:rPr sz="1600" b="1">
+                <a:solidFill>
+                  <a:srgbClr val="4A4BD6"/>
+                </a:solidFill>
+                <a:latin typeface="Calibri"/>
+              </a:rPr>
+              <a:t>▸  </a:t>
+            </a:r>
+            <a:r>
+              <a:rPr sz="1600" b="0">
+                <a:solidFill>
+                  <a:srgbClr val="37424F"/>
+                </a:solidFill>
+                <a:latin typeface="Calibri"/>
+              </a:rPr>
+              <a:t>Reliability: standard forecast </a:t>
+            </a:r>
+            <a:r>
+              <a:rPr sz="1600" b="1">
+                <a:solidFill>
+                  <a:srgbClr val="111820"/>
+                </a:solidFill>
+                <a:latin typeface="Calibri"/>
+              </a:rPr>
+              <a:t>exceeded from 2030-31 (NSW/VIC)</a:t>
+            </a:r>
+            <a:r>
+              <a:rPr sz="1600" b="0">
+                <a:solidFill>
+                  <a:srgbClr val="37424F"/>
+                </a:solidFill>
+                <a:latin typeface="Calibri"/>
+              </a:rPr>
+              <a:t> under committed+anticipated developments.</a:t>
             </a:r>
           </a:p>
           <a:p>
@@ -23019,6 +23101,52 @@
                 </a:solidFill>
                 <a:latin typeface="Calibri"/>
               </a:rPr>
+              <a:t>AEMO 2026 ESOO: </a:t>
+            </a:r>
+            <a:r>
+              <a:rPr sz="1600" b="1">
+                <a:solidFill>
+                  <a:srgbClr val="111820"/>
+                </a:solidFill>
+                <a:latin typeface="Calibri"/>
+              </a:rPr>
+              <a:t>9.1 GW connected in 2025-26</a:t>
+            </a:r>
+            <a:r>
+              <a:rPr sz="1600" b="0">
+                <a:solidFill>
+                  <a:srgbClr val="37424F"/>
+                </a:solidFill>
+                <a:latin typeface="Calibri"/>
+              </a:rPr>
+              <a:t> (&gt;2× the prior year); ~40 GW committed+anticipated — more than half today's NEM capacity.</a:t>
+            </a:r>
+          </a:p>
+          <a:p>
+            <a:pPr>
+              <a:lnSpc>
+                <a:spcPct val="105000"/>
+              </a:lnSpc>
+              <a:spcAft>
+                <a:spcPts val="1100"/>
+              </a:spcAft>
+            </a:pPr>
+            <a:r>
+              <a:rPr sz="1600" b="1">
+                <a:solidFill>
+                  <a:srgbClr val="2F7D3A"/>
+                </a:solidFill>
+                <a:latin typeface="Calibri"/>
+              </a:rPr>
+              <a:t>▸  </a:t>
+            </a:r>
+            <a:r>
+              <a:rPr sz="1600" b="0">
+                <a:solidFill>
+                  <a:srgbClr val="37424F"/>
+                </a:solidFill>
+                <a:latin typeface="Calibri"/>
+              </a:rPr>
               <a:t>Back-test: of </a:t>
             </a:r>
             <a:r>
@@ -25390,7 +25518,7 @@
                 </a:solidFill>
                 <a:latin typeface="Calibri"/>
               </a:rPr>
-              <a:t>Sourced from the AusEnergy “Lens” — a live database over the AEMO dispatch decade (2015→2026), ISP 2026, Open Electricity and the CER. As-at August 2026. The calculators and the storage/leverage figures are transparent teaching models, not planning tools — the point is the shape of the answer.</a:t>
+              <a:t>Sourced from the AusEnergy “Lens” — a live database over the AEMO dispatch decade (2015→2026), the 2026 ESOO + ISP 2026, Open Electricity and the CER. As-at August 2026. The calculators and the storage/leverage figures are transparent teaching models, not planning tools — the point is the shape of the answer.</a:t>
             </a:r>
           </a:p>
         </p:txBody>

</xml_diff>